<commit_message>
fix: documento sin notas sobre el propio texto ni GitFlow; presentación sin notas del orador
El guion queda en presentacion/ (general y uno por integrante).
</commit_message>
<xml_diff>
--- a/presentacion/Grupo2_CasoParquimetros_Presentacion.pptx
+++ b/presentacion/Grupo2_CasoParquimetros_Presentacion.pptx
@@ -468,1571 +468,6 @@
     </a:lvl9pPr>
   </p:notesStyle>
 </p:notesMaster>
-</file>
-
-<file path=ppt/notesSlides/notesSlide1.xml><?xml version="1.0" encoding="utf-8"?>
-<p:notes xmlns:a="http://schemas.openxmlformats.org/drawingml/2006/main" xmlns:p="http://schemas.openxmlformats.org/presentationml/2006/main" xmlns:r="http://schemas.openxmlformats.org/officeDocument/2006/relationships">
-  <p:cSld>
-    <p:spTree>
-      <p:nvGrpSpPr>
-        <p:cNvPr id="1" name=""/>
-        <p:cNvGrpSpPr/>
-        <p:nvPr/>
-      </p:nvGrpSpPr>
-      <p:grpSpPr>
-        <a:xfrm>
-          <a:off x="0" y="0"/>
-          <a:ext cx="0" cy="0"/>
-          <a:chOff x="0" y="0"/>
-          <a:chExt cx="0" cy="0"/>
-        </a:xfrm>
-      </p:grpSpPr>
-      <p:sp>
-        <p:nvSpPr>
-          <p:cNvPr id="2" name="Slide Image Placeholder 1"/>
-          <p:cNvSpPr>
-            <a:spLocks noGrp="1"/>
-          </p:cNvSpPr>
-          <p:nvPr>
-            <p:ph type="sldImg" idx="2"/>
-          </p:nvPr>
-        </p:nvSpPr>
-        <p:spPr/>
-      </p:sp>
-      <p:sp>
-        <p:nvSpPr>
-          <p:cNvPr id="3" name="Notes Placeholder 2"/>
-          <p:cNvSpPr>
-            <a:spLocks noGrp="1"/>
-          </p:cNvSpPr>
-          <p:nvPr>
-            <p:ph type="body" idx="3" sz="quarter"/>
-          </p:nvPr>
-        </p:nvSpPr>
-        <p:spPr/>
-        <p:txBody>
-          <a:bodyPr/>
-          <a:lstStyle/>
-          <a:p>
-            <a:r>
-              <a:t>Santiago · Portada</a:t>
-            </a:r>
-          </a:p>
-          <a:p/>
-          <a:p>
-            <a:r>
-              <a:t>Buenos días. Somos el Grupo 2: Jemima Chavajay, Byron Par y Santiago Barrera. Presentamos el caso</a:t>
-            </a:r>
-          </a:p>
-          <a:p>
-            <a:r>
-              <a:t>cuatro, Repensando los parquímetros. Nuestra propuesta se llama SIEP, Sistema Integrado de</a:t>
-            </a:r>
-          </a:p>
-          <a:p>
-            <a:r>
-              <a:t>Estacionamiento en la vía Pública, y la vamos a defender desde las cuatro perspectivas que pide la</a:t>
-            </a:r>
-          </a:p>
-          <a:p>
-            <a:r>
-              <a:t>consigna: arquitectura del software, calidad, arquitectura en el ciclo de vida y arquitectura de la</a:t>
-            </a:r>
-          </a:p>
-          <a:p>
-            <a:r>
-              <a:t>información.</a:t>
-            </a:r>
-          </a:p>
-        </p:txBody>
-      </p:sp>
-      <p:sp>
-        <p:nvSpPr>
-          <p:cNvPr id="4" name="Slide Number Placeholder 3"/>
-          <p:cNvSpPr>
-            <a:spLocks noGrp="1"/>
-          </p:cNvSpPr>
-          <p:nvPr>
-            <p:ph type="sldNum" idx="5" sz="quarter"/>
-          </p:nvPr>
-        </p:nvSpPr>
-        <p:spPr/>
-      </p:sp>
-    </p:spTree>
-  </p:cSld>
-  <p:clrMapOvr>
-    <a:masterClrMapping/>
-  </p:clrMapOvr>
-</p:notes>
-</file>
-
-<file path=ppt/notesSlides/notesSlide10.xml><?xml version="1.0" encoding="utf-8"?>
-<p:notes xmlns:a="http://schemas.openxmlformats.org/drawingml/2006/main" xmlns:p="http://schemas.openxmlformats.org/presentationml/2006/main" xmlns:r="http://schemas.openxmlformats.org/officeDocument/2006/relationships">
-  <p:cSld>
-    <p:spTree>
-      <p:nvGrpSpPr>
-        <p:cNvPr id="1" name=""/>
-        <p:cNvGrpSpPr/>
-        <p:nvPr/>
-      </p:nvGrpSpPr>
-      <p:grpSpPr>
-        <a:xfrm>
-          <a:off x="0" y="0"/>
-          <a:ext cx="0" cy="0"/>
-          <a:chOff x="0" y="0"/>
-          <a:chExt cx="0" cy="0"/>
-        </a:xfrm>
-      </p:grpSpPr>
-      <p:sp>
-        <p:nvSpPr>
-          <p:cNvPr id="2" name="Slide Image Placeholder 1"/>
-          <p:cNvSpPr>
-            <a:spLocks noGrp="1"/>
-          </p:cNvSpPr>
-          <p:nvPr>
-            <p:ph type="sldImg" idx="2"/>
-          </p:nvPr>
-        </p:nvSpPr>
-        <p:spPr/>
-      </p:sp>
-      <p:sp>
-        <p:nvSpPr>
-          <p:cNvPr id="3" name="Notes Placeholder 2"/>
-          <p:cNvSpPr>
-            <a:spLocks noGrp="1"/>
-          </p:cNvSpPr>
-          <p:nvPr>
-            <p:ph type="body" idx="3" sz="quarter"/>
-          </p:nvPr>
-        </p:nvSpPr>
-        <p:spPr/>
-        <p:txBody>
-          <a:bodyPr/>
-          <a:lstStyle/>
-          <a:p>
-            <a:r>
-              <a:t>Jemima · Calidad: los números que se comprometen</a:t>
-            </a:r>
-          </a:p>
-          <a:p/>
-          <a:p>
-            <a:r>
-              <a:t>Usamos los dos modelos de ISO 9126 del programa: calidad del producto y calidad en uso.</a:t>
-            </a:r>
-          </a:p>
-          <a:p>
-            <a:r>
-              <a:t>[CLIC] Eficacia: setenta y dos por ciento completa el pago sin ayuda.</a:t>
-            </a:r>
-          </a:p>
-          <a:p>
-            <a:r>
-              <a:t>[CLIC] Rendimiento: el verificador sabe si una placa pagó en dos segundos.</a:t>
-            </a:r>
-          </a:p>
-          <a:p>
-            <a:r>
-              <a:t>[CLIC] Disponibilidad: cero pagos perdidos aunque se caiga la red.</a:t>
-            </a:r>
-          </a:p>
-          <a:p>
-            <a:r>
-              <a:t>[CLIC] Seguridad: el cien por ciento de las multas con foto, hora, ubicación y la firma del oficial.</a:t>
-            </a:r>
-          </a:p>
-          <a:p>
-            <a:r>
-              <a:t>Cada entrega se acepta con una prueba de desempeño, ahora en la calle y con doce personas.</a:t>
-            </a:r>
-          </a:p>
-        </p:txBody>
-      </p:sp>
-      <p:sp>
-        <p:nvSpPr>
-          <p:cNvPr id="4" name="Slide Number Placeholder 3"/>
-          <p:cNvSpPr>
-            <a:spLocks noGrp="1"/>
-          </p:cNvSpPr>
-          <p:nvPr>
-            <p:ph type="sldNum" idx="5" sz="quarter"/>
-          </p:nvPr>
-        </p:nvSpPr>
-        <p:spPr/>
-      </p:sp>
-    </p:spTree>
-  </p:cSld>
-  <p:clrMapOvr>
-    <a:masterClrMapping/>
-  </p:clrMapOvr>
-</p:notes>
-</file>
-
-<file path=ppt/notesSlides/notesSlide11.xml><?xml version="1.0" encoding="utf-8"?>
-<p:notes xmlns:a="http://schemas.openxmlformats.org/drawingml/2006/main" xmlns:p="http://schemas.openxmlformats.org/presentationml/2006/main" xmlns:r="http://schemas.openxmlformats.org/officeDocument/2006/relationships">
-  <p:cSld>
-    <p:spTree>
-      <p:nvGrpSpPr>
-        <p:cNvPr id="1" name=""/>
-        <p:cNvGrpSpPr/>
-        <p:nvPr/>
-      </p:nvGrpSpPr>
-      <p:grpSpPr>
-        <a:xfrm>
-          <a:off x="0" y="0"/>
-          <a:ext cx="0" cy="0"/>
-          <a:chOff x="0" y="0"/>
-          <a:chExt cx="0" cy="0"/>
-        </a:xfrm>
-      </p:grpSpPr>
-      <p:sp>
-        <p:nvSpPr>
-          <p:cNvPr id="2" name="Slide Image Placeholder 1"/>
-          <p:cNvSpPr>
-            <a:spLocks noGrp="1"/>
-          </p:cNvSpPr>
-          <p:nvPr>
-            <p:ph type="sldImg" idx="2"/>
-          </p:nvPr>
-        </p:nvSpPr>
-        <p:spPr/>
-      </p:sp>
-      <p:sp>
-        <p:nvSpPr>
-          <p:cNvPr id="3" name="Notes Placeholder 2"/>
-          <p:cNvSpPr>
-            <a:spLocks noGrp="1"/>
-          </p:cNvSpPr>
-          <p:nvPr>
-            <p:ph type="body" idx="3" sz="quarter"/>
-          </p:nvPr>
-        </p:nvSpPr>
-        <p:spPr/>
-        <p:txBody>
-          <a:bodyPr/>
-          <a:lstStyle/>
-          <a:p>
-            <a:r>
-              <a:t>Jemima · Arquitectura de la información</a:t>
-            </a:r>
-          </a:p>
-          <a:p/>
-          <a:p>
-            <a:r>
-              <a:t>La arquitectura de la información organiza los contenidos para que la gente los encuentre. La</a:t>
-            </a:r>
-          </a:p>
-          <a:p>
-            <a:r>
-              <a:t>organizamos por momento de uso.</a:t>
-            </a:r>
-          </a:p>
-          <a:p>
-            <a:r>
-              <a:t>[CLIC] Antes: la señal con el color de la banqueta y el mapa en la app.</a:t>
-            </a:r>
-          </a:p>
-          <a:p>
-            <a:r>
-              <a:t>[CLIC] Durante: tres pasos, placa, tiempo y pago, con la tarifa siempre arriba.</a:t>
-            </a:r>
-          </a:p>
-          <a:p>
-            <a:r>
-              <a:t>[CLIC] Después: comprobante con folio, aviso antes de vencer y cómo reclamar.</a:t>
-            </a:r>
-          </a:p>
-        </p:txBody>
-      </p:sp>
-      <p:sp>
-        <p:nvSpPr>
-          <p:cNvPr id="4" name="Slide Number Placeholder 3"/>
-          <p:cNvSpPr>
-            <a:spLocks noGrp="1"/>
-          </p:cNvSpPr>
-          <p:nvPr>
-            <p:ph type="sldNum" idx="5" sz="quarter"/>
-          </p:nvPr>
-        </p:nvSpPr>
-        <p:spPr/>
-      </p:sp>
-    </p:spTree>
-  </p:cSld>
-  <p:clrMapOvr>
-    <a:masterClrMapping/>
-  </p:clrMapOvr>
-</p:notes>
-</file>
-
-<file path=ppt/notesSlides/notesSlide12.xml><?xml version="1.0" encoding="utf-8"?>
-<p:notes xmlns:a="http://schemas.openxmlformats.org/drawingml/2006/main" xmlns:p="http://schemas.openxmlformats.org/presentationml/2006/main" xmlns:r="http://schemas.openxmlformats.org/officeDocument/2006/relationships">
-  <p:cSld>
-    <p:spTree>
-      <p:nvGrpSpPr>
-        <p:cNvPr id="1" name=""/>
-        <p:cNvGrpSpPr/>
-        <p:nvPr/>
-      </p:nvGrpSpPr>
-      <p:grpSpPr>
-        <a:xfrm>
-          <a:off x="0" y="0"/>
-          <a:ext cx="0" cy="0"/>
-          <a:chOff x="0" y="0"/>
-          <a:chExt cx="0" cy="0"/>
-        </a:xfrm>
-      </p:grpSpPr>
-      <p:sp>
-        <p:nvSpPr>
-          <p:cNvPr id="2" name="Slide Image Placeholder 1"/>
-          <p:cNvSpPr>
-            <a:spLocks noGrp="1"/>
-          </p:cNvSpPr>
-          <p:nvPr>
-            <p:ph type="sldImg" idx="2"/>
-          </p:nvPr>
-        </p:nvSpPr>
-        <p:spPr/>
-      </p:sp>
-      <p:sp>
-        <p:nvSpPr>
-          <p:cNvPr id="3" name="Notes Placeholder 2"/>
-          <p:cNvSpPr>
-            <a:spLocks noGrp="1"/>
-          </p:cNvSpPr>
-          <p:nvPr>
-            <p:ph type="body" idx="3" sz="quarter"/>
-          </p:nvPr>
-        </p:nvSpPr>
-        <p:spPr/>
-        <p:txBody>
-          <a:bodyPr/>
-          <a:lstStyle/>
-          <a:p>
-            <a:r>
-              <a:t>Jemima · Prototipo</a:t>
-            </a:r>
-          </a:p>
-          <a:p/>
-          <a:p>
-            <a:r>
-              <a:t>Desarrollamos una parte del sistema: la pantalla del parquímetro. Usa el tarifario real de la</a:t>
-            </a:r>
-          </a:p>
-          <a:p>
-            <a:r>
-              <a:t>capital y trae un modo de prueba que cronometra cada intento y calcula si llegamos al setenta y dos</a:t>
-            </a:r>
-          </a:p>
-          <a:p>
-            <a:r>
-              <a:t>por ciento. Y en el paso de pago dice lo que el cuidacarros no quiere que se sepa: este es el único</a:t>
-            </a:r>
-          </a:p>
-          <a:p>
-            <a:r>
-              <a:t>cobro. Santiago cierra con cómo se construye.</a:t>
-            </a:r>
-          </a:p>
-        </p:txBody>
-      </p:sp>
-      <p:sp>
-        <p:nvSpPr>
-          <p:cNvPr id="4" name="Slide Number Placeholder 3"/>
-          <p:cNvSpPr>
-            <a:spLocks noGrp="1"/>
-          </p:cNvSpPr>
-          <p:nvPr>
-            <p:ph type="sldNum" idx="5" sz="quarter"/>
-          </p:nvPr>
-        </p:nvSpPr>
-        <p:spPr/>
-      </p:sp>
-    </p:spTree>
-  </p:cSld>
-  <p:clrMapOvr>
-    <a:masterClrMapping/>
-  </p:clrMapOvr>
-</p:notes>
-</file>
-
-<file path=ppt/notesSlides/notesSlide13.xml><?xml version="1.0" encoding="utf-8"?>
-<p:notes xmlns:a="http://schemas.openxmlformats.org/drawingml/2006/main" xmlns:p="http://schemas.openxmlformats.org/presentationml/2006/main" xmlns:r="http://schemas.openxmlformats.org/officeDocument/2006/relationships">
-  <p:cSld>
-    <p:spTree>
-      <p:nvGrpSpPr>
-        <p:cNvPr id="1" name=""/>
-        <p:cNvGrpSpPr/>
-        <p:nvPr/>
-      </p:nvGrpSpPr>
-      <p:grpSpPr>
-        <a:xfrm>
-          <a:off x="0" y="0"/>
-          <a:ext cx="0" cy="0"/>
-          <a:chOff x="0" y="0"/>
-          <a:chExt cx="0" cy="0"/>
-        </a:xfrm>
-      </p:grpSpPr>
-      <p:sp>
-        <p:nvSpPr>
-          <p:cNvPr id="2" name="Slide Image Placeholder 1"/>
-          <p:cNvSpPr>
-            <a:spLocks noGrp="1"/>
-          </p:cNvSpPr>
-          <p:nvPr>
-            <p:ph type="sldImg" idx="2"/>
-          </p:nvPr>
-        </p:nvSpPr>
-        <p:spPr/>
-      </p:sp>
-      <p:sp>
-        <p:nvSpPr>
-          <p:cNvPr id="3" name="Notes Placeholder 2"/>
-          <p:cNvSpPr>
-            <a:spLocks noGrp="1"/>
-          </p:cNvSpPr>
-          <p:nvPr>
-            <p:ph type="body" idx="3" sz="quarter"/>
-          </p:nvPr>
-        </p:nvSpPr>
-        <p:spPr/>
-        <p:txBody>
-          <a:bodyPr/>
-          <a:lstStyle/>
-          <a:p>
-            <a:r>
-              <a:t>Santiago · Arquitectura en el ciclo de vida</a:t>
-            </a:r>
-          </a:p>
-          <a:p/>
-          <a:p>
-            <a:r>
-              <a:t>Para elegir cómo trabajar usamos los siete factores de la clase. La pantalla no se sabe cómo debe</a:t>
-            </a:r>
-          </a:p>
-          <a:p>
-            <a:r>
-              <a:t>quedar hasta probarla con gente, cada Delegación quiere algo distinto y hay riesgos fuertes al</a:t>
-            </a:r>
-          </a:p>
-          <a:p>
-            <a:r>
-              <a:t>inicio. Por eso combinamos dos métodos.</a:t>
-            </a:r>
-          </a:p>
-          <a:p>
-            <a:r>
-              <a:t>[CLIC] Por fuera, el modelo en espiral: en cada vuelta se revisan primero los riesgos, igual que</a:t>
-            </a:r>
-          </a:p>
-          <a:p>
-            <a:r>
-              <a:t>hizo Smartmedia probando y corrigiendo. Por dentro,</a:t>
-            </a:r>
-          </a:p>
-          <a:p>
-            <a:r>
-              <a:t>Scrum con los cuatro pasos de arquitectura de la lámina: especificar y priorizar casos de uso,</a:t>
-            </a:r>
-          </a:p>
-          <a:p>
-            <a:r>
-              <a:t>arquitectura base en el primer sprint y refinamiento en cada sprint.</a:t>
-            </a:r>
-          </a:p>
-          <a:p>
-            <a:r>
-              <a:t>[CLIC] Cuatro fases: concertación con la colonia piloto; pago por placa y verificación; app y red</a:t>
-            </a:r>
-          </a:p>
-          <a:p>
-            <a:r>
-              <a:t>monitoreada; y, con datos, sensores.</a:t>
-            </a:r>
-          </a:p>
-        </p:txBody>
-      </p:sp>
-      <p:sp>
-        <p:nvSpPr>
-          <p:cNvPr id="4" name="Slide Number Placeholder 3"/>
-          <p:cNvSpPr>
-            <a:spLocks noGrp="1"/>
-          </p:cNvSpPr>
-          <p:nvPr>
-            <p:ph type="sldNum" idx="5" sz="quarter"/>
-          </p:nvPr>
-        </p:nvSpPr>
-        <p:spPr/>
-      </p:sp>
-    </p:spTree>
-  </p:cSld>
-  <p:clrMapOvr>
-    <a:masterClrMapping/>
-  </p:clrMapOvr>
-</p:notes>
-</file>
-
-<file path=ppt/notesSlides/notesSlide14.xml><?xml version="1.0" encoding="utf-8"?>
-<p:notes xmlns:a="http://schemas.openxmlformats.org/drawingml/2006/main" xmlns:p="http://schemas.openxmlformats.org/presentationml/2006/main" xmlns:r="http://schemas.openxmlformats.org/officeDocument/2006/relationships">
-  <p:cSld>
-    <p:spTree>
-      <p:nvGrpSpPr>
-        <p:cNvPr id="1" name=""/>
-        <p:cNvGrpSpPr/>
-        <p:nvPr/>
-      </p:nvGrpSpPr>
-      <p:grpSpPr>
-        <a:xfrm>
-          <a:off x="0" y="0"/>
-          <a:ext cx="0" cy="0"/>
-          <a:chOff x="0" y="0"/>
-          <a:chExt cx="0" cy="0"/>
-        </a:xfrm>
-      </p:grpSpPr>
-      <p:sp>
-        <p:nvSpPr>
-          <p:cNvPr id="2" name="Slide Image Placeholder 1"/>
-          <p:cNvSpPr>
-            <a:spLocks noGrp="1"/>
-          </p:cNvSpPr>
-          <p:nvPr>
-            <p:ph type="sldImg" idx="2"/>
-          </p:nvPr>
-        </p:nvSpPr>
-        <p:spPr/>
-      </p:sp>
-      <p:sp>
-        <p:nvSpPr>
-          <p:cNvPr id="3" name="Notes Placeholder 2"/>
-          <p:cNvSpPr>
-            <a:spLocks noGrp="1"/>
-          </p:cNvSpPr>
-          <p:nvPr>
-            <p:ph type="body" idx="3" sz="quarter"/>
-          </p:nvPr>
-        </p:nvSpPr>
-        <p:spPr/>
-        <p:txBody>
-          <a:bodyPr/>
-          <a:lstStyle/>
-          <a:p>
-            <a:r>
-              <a:t>Santiago · Los cobros de personas ajenas</a:t>
-            </a:r>
-          </a:p>
-          <a:p/>
-          <a:p>
-            <a:r>
-              <a:t>Volvemos al cuidacarros, porque es el problema que más se parece a Guatemala.</a:t>
-            </a:r>
-          </a:p>
-          <a:p>
-            <a:r>
-              <a:t>[CLIC] Información: la pantalla dice que es el único cobro.</a:t>
-            </a:r>
-          </a:p>
-          <a:p>
-            <a:r>
-              <a:t>[CLIC] Software: el conductor puede reportar un cobro sin dar su nombre, y el sistema marca las</a:t>
-            </a:r>
-          </a:p>
-          <a:p>
-            <a:r>
-              <a:t>cuadras que están llenas pero donde casi nadie paga: ahí hay alguien cobrando.</a:t>
-            </a:r>
-          </a:p>
-          <a:p>
-            <a:r>
-              <a:t>[CLIC] Ciclo de vida: antes de instalar, contar cuántos cuidacarros hay y acordar con la</a:t>
-            </a:r>
-          </a:p>
-          <a:p>
-            <a:r>
-              <a:t>Procuraduría de los Derechos Humanos cómo se actúa, como se hizo en Antigua.</a:t>
-            </a:r>
-          </a:p>
-          <a:p>
-            <a:r>
-              <a:t>[CLIC] Y una opción para la Delegación: ofrecer trabajo formal de orientación, pagado con el treinta por ciento comunitario.</a:t>
-            </a:r>
-          </a:p>
-        </p:txBody>
-      </p:sp>
-      <p:sp>
-        <p:nvSpPr>
-          <p:cNvPr id="4" name="Slide Number Placeholder 3"/>
-          <p:cNvSpPr>
-            <a:spLocks noGrp="1"/>
-          </p:cNvSpPr>
-          <p:nvPr>
-            <p:ph type="sldNum" idx="5" sz="quarter"/>
-          </p:nvPr>
-        </p:nvSpPr>
-        <p:spPr/>
-      </p:sp>
-    </p:spTree>
-  </p:cSld>
-  <p:clrMapOvr>
-    <a:masterClrMapping/>
-  </p:clrMapOvr>
-</p:notes>
-</file>
-
-<file path=ppt/notesSlides/notesSlide15.xml><?xml version="1.0" encoding="utf-8"?>
-<p:notes xmlns:a="http://schemas.openxmlformats.org/drawingml/2006/main" xmlns:p="http://schemas.openxmlformats.org/presentationml/2006/main" xmlns:r="http://schemas.openxmlformats.org/officeDocument/2006/relationships">
-  <p:cSld>
-    <p:spTree>
-      <p:nvGrpSpPr>
-        <p:cNvPr id="1" name=""/>
-        <p:cNvGrpSpPr/>
-        <p:nvPr/>
-      </p:nvGrpSpPr>
-      <p:grpSpPr>
-        <a:xfrm>
-          <a:off x="0" y="0"/>
-          <a:ext cx="0" cy="0"/>
-          <a:chOff x="0" y="0"/>
-          <a:chExt cx="0" cy="0"/>
-        </a:xfrm>
-      </p:grpSpPr>
-      <p:sp>
-        <p:nvSpPr>
-          <p:cNvPr id="2" name="Slide Image Placeholder 1"/>
-          <p:cNvSpPr>
-            <a:spLocks noGrp="1"/>
-          </p:cNvSpPr>
-          <p:nvPr>
-            <p:ph type="sldImg" idx="2"/>
-          </p:nvPr>
-        </p:nvSpPr>
-        <p:spPr/>
-      </p:sp>
-      <p:sp>
-        <p:nvSpPr>
-          <p:cNvPr id="3" name="Notes Placeholder 2"/>
-          <p:cNvSpPr>
-            <a:spLocks noGrp="1"/>
-          </p:cNvSpPr>
-          <p:nvPr>
-            <p:ph type="body" idx="3" sz="quarter"/>
-          </p:nvPr>
-        </p:nvSpPr>
-        <p:spPr/>
-        <p:txBody>
-          <a:bodyPr/>
-          <a:lstStyle/>
-          <a:p>
-            <a:r>
-              <a:t>Santiago · Cierre</a:t>
-            </a:r>
-          </a:p>
-          <a:p/>
-          <a:p>
-            <a:r>
-              <a:t>Tres ideas para llevarse. La pantalla era la mitad del problema. Las funciones que faltaban ya</a:t>
-            </a:r>
-          </a:p>
-          <a:p>
-            <a:r>
-              <a:t>estaban en el equipo. Y lo que se cobra se publica, porque sin confianza no hay sistema. Gracias;</a:t>
-            </a:r>
-          </a:p>
-          <a:p>
-            <a:r>
-              <a:t>con gusto respondemos sus preguntas.</a:t>
-            </a:r>
-          </a:p>
-        </p:txBody>
-      </p:sp>
-      <p:sp>
-        <p:nvSpPr>
-          <p:cNvPr id="4" name="Slide Number Placeholder 3"/>
-          <p:cNvSpPr>
-            <a:spLocks noGrp="1"/>
-          </p:cNvSpPr>
-          <p:nvPr>
-            <p:ph type="sldNum" idx="5" sz="quarter"/>
-          </p:nvPr>
-        </p:nvSpPr>
-        <p:spPr/>
-      </p:sp>
-    </p:spTree>
-  </p:cSld>
-  <p:clrMapOvr>
-    <a:masterClrMapping/>
-  </p:clrMapOvr>
-</p:notes>
-</file>
-
-<file path=ppt/notesSlides/notesSlide2.xml><?xml version="1.0" encoding="utf-8"?>
-<p:notes xmlns:a="http://schemas.openxmlformats.org/drawingml/2006/main" xmlns:p="http://schemas.openxmlformats.org/presentationml/2006/main" xmlns:r="http://schemas.openxmlformats.org/officeDocument/2006/relationships">
-  <p:cSld>
-    <p:spTree>
-      <p:nvGrpSpPr>
-        <p:cNvPr id="1" name=""/>
-        <p:cNvGrpSpPr/>
-        <p:nvPr/>
-      </p:nvGrpSpPr>
-      <p:grpSpPr>
-        <a:xfrm>
-          <a:off x="0" y="0"/>
-          <a:ext cx="0" cy="0"/>
-          <a:chOff x="0" y="0"/>
-          <a:chExt cx="0" cy="0"/>
-        </a:xfrm>
-      </p:grpSpPr>
-      <p:sp>
-        <p:nvSpPr>
-          <p:cNvPr id="2" name="Slide Image Placeholder 1"/>
-          <p:cNvSpPr>
-            <a:spLocks noGrp="1"/>
-          </p:cNvSpPr>
-          <p:nvPr>
-            <p:ph type="sldImg" idx="2"/>
-          </p:nvPr>
-        </p:nvSpPr>
-        <p:spPr/>
-      </p:sp>
-      <p:sp>
-        <p:nvSpPr>
-          <p:cNvPr id="3" name="Notes Placeholder 2"/>
-          <p:cNvSpPr>
-            <a:spLocks noGrp="1"/>
-          </p:cNvSpPr>
-          <p:nvPr>
-            <p:ph type="body" idx="3" sz="quarter"/>
-          </p:nvPr>
-        </p:nvSpPr>
-        <p:spPr/>
-        <p:txBody>
-          <a:bodyPr/>
-          <a:lstStyle/>
-          <a:p>
-            <a:r>
-              <a:t>Santiago · El caso en una lámina</a:t>
-            </a:r>
-          </a:p>
-          <a:p/>
-          <a:p>
-            <a:r>
-              <a:t>SERVIparq es el programa del gobierno de la Ciudad de México que opera los parquímetros. Su meta es</a:t>
-            </a:r>
-          </a:p>
-          <a:p>
-            <a:r>
-              <a:t>urbana: que un cajón que vale hasta doscientos mil pesos deje de ser de uno solo y rote.</a:t>
-            </a:r>
-          </a:p>
-          <a:p>
-            <a:r>
-              <a:t>[CLIC] Lo recaudado se reparte setenta por ciento para operar y treinta para la comunidad.</a:t>
-            </a:r>
-          </a:p>
-          <a:p>
-            <a:r>
-              <a:t>[CLIC] En 2012 llega Margarita Patiño, hace un diagnóstico y encuentra seis problemas.</a:t>
-            </a:r>
-          </a:p>
-          <a:p>
-            <a:r>
-              <a:t>[CLIC] Contrata a Smartmedia, una empresa de diseño. Le pide a la gente que haga tareas con el</a:t>
-            </a:r>
-          </a:p>
-          <a:p>
-            <a:r>
-              <a:t>parquímetro y mide si encuentra y entiende la información. Hasta armaron una calle de mentira en una</a:t>
-            </a:r>
-          </a:p>
-          <a:p>
-            <a:r>
-              <a:t>sala para que los participantes actuaran la situación. Nuestra conclusión: Smartmedia arregló la</a:t>
-            </a:r>
-          </a:p>
-          <a:p>
-            <a:r>
-              <a:t>pantalla, pero tres de los seis problemas no tienen que ver con la pantalla.</a:t>
-            </a:r>
-          </a:p>
-        </p:txBody>
-      </p:sp>
-      <p:sp>
-        <p:nvSpPr>
-          <p:cNvPr id="4" name="Slide Number Placeholder 3"/>
-          <p:cNvSpPr>
-            <a:spLocks noGrp="1"/>
-          </p:cNvSpPr>
-          <p:nvPr>
-            <p:ph type="sldNum" idx="5" sz="quarter"/>
-          </p:nvPr>
-        </p:nvSpPr>
-        <p:spPr/>
-      </p:sp>
-    </p:spTree>
-  </p:cSld>
-  <p:clrMapOvr>
-    <a:masterClrMapping/>
-  </p:clrMapOvr>
-</p:notes>
-</file>
-
-<file path=ppt/notesSlides/notesSlide3.xml><?xml version="1.0" encoding="utf-8"?>
-<p:notes xmlns:a="http://schemas.openxmlformats.org/drawingml/2006/main" xmlns:p="http://schemas.openxmlformats.org/presentationml/2006/main" xmlns:r="http://schemas.openxmlformats.org/officeDocument/2006/relationships">
-  <p:cSld>
-    <p:spTree>
-      <p:nvGrpSpPr>
-        <p:cNvPr id="1" name=""/>
-        <p:cNvGrpSpPr/>
-        <p:nvPr/>
-      </p:nvGrpSpPr>
-      <p:grpSpPr>
-        <a:xfrm>
-          <a:off x="0" y="0"/>
-          <a:ext cx="0" cy="0"/>
-          <a:chOff x="0" y="0"/>
-          <a:chExt cx="0" cy="0"/>
-        </a:xfrm>
-      </p:grpSpPr>
-      <p:sp>
-        <p:nvSpPr>
-          <p:cNvPr id="2" name="Slide Image Placeholder 1"/>
-          <p:cNvSpPr>
-            <a:spLocks noGrp="1"/>
-          </p:cNvSpPr>
-          <p:nvPr>
-            <p:ph type="sldImg" idx="2"/>
-          </p:nvPr>
-        </p:nvSpPr>
-        <p:spPr/>
-      </p:sp>
-      <p:sp>
-        <p:nvSpPr>
-          <p:cNvPr id="3" name="Notes Placeholder 2"/>
-          <p:cNvSpPr>
-            <a:spLocks noGrp="1"/>
-          </p:cNvSpPr>
-          <p:nvPr>
-            <p:ph type="body" idx="3" sz="quarter"/>
-          </p:nvPr>
-        </p:nvSpPr>
-        <p:spPr/>
-        <p:txBody>
-          <a:bodyPr/>
-          <a:lstStyle/>
-          <a:p>
-            <a:r>
-              <a:t>Santiago · Guatemala: cómo funciona y quién más cobra</a:t>
-            </a:r>
-          </a:p>
-          <a:p/>
-          <a:p>
-            <a:r>
-              <a:t>Trajimos el caso a Guatemala. En la capital, la municipalidad cobra tres quetzales por media hora</a:t>
-            </a:r>
-          </a:p>
-          <a:p>
-            <a:r>
-              <a:t>según su acuerdo COM-40-2022, y la banqueta se pinta por colores: blanco se puede, rojo no. EMETRA,</a:t>
-            </a:r>
-          </a:p>
-          <a:p>
-            <a:r>
-              <a:t>la empresa municipal de tránsito, anunció que se va a poder pagar con una aplicación.</a:t>
-            </a:r>
-          </a:p>
-          <a:p>
-            <a:r>
-              <a:t>[CLIC] Y aquí aparece algo que el sistema no controla: personas que no son de la municipalidad y</a:t>
-            </a:r>
-          </a:p>
-          <a:p>
-            <a:r>
-              <a:t>cobran por dejar estacionar, los cuidacarros. En el caso, que pasa en México, les dicen franeleros.</a:t>
-            </a:r>
-          </a:p>
-          <a:p>
-            <a:r>
-              <a:t>En un solo operativo se retiraron dos mil quinientos objetos que apartaban lugares. En</a:t>
-            </a:r>
-          </a:p>
-          <a:p>
-            <a:r>
-              <a:t>abril, en la zona 13, el Ministerio Público identificó a treinta y tres personas que cobraban hasta</a:t>
-            </a:r>
-          </a:p>
-          <a:p>
-            <a:r>
-              <a:t>cincuenta dólares a turistas.</a:t>
-            </a:r>
-          </a:p>
-          <a:p>
-            <a:r>
-              <a:t>[CLIC] Y Antigua: su marbete digital, MarbEx, casi duplicó la recaudación, de siete a doce</a:t>
-            </a:r>
-          </a:p>
-          <a:p>
-            <a:r>
-              <a:t>millones, pero la Corte de Constitucionalidad suspendió justamente la base de datos de placas y la</a:t>
-            </a:r>
-          </a:p>
-          <a:p>
-            <a:r>
-              <a:t>multa de quinientos quetzales. La lección: no basta con cobrar, hay que hacerlo con base legal y que</a:t>
-            </a:r>
-          </a:p>
-          <a:p>
-            <a:r>
-              <a:t>la gente confíe. Le doy la palabra a Jemima, que les muestra los problemas.</a:t>
-            </a:r>
-          </a:p>
-        </p:txBody>
-      </p:sp>
-      <p:sp>
-        <p:nvSpPr>
-          <p:cNvPr id="4" name="Slide Number Placeholder 3"/>
-          <p:cNvSpPr>
-            <a:spLocks noGrp="1"/>
-          </p:cNvSpPr>
-          <p:nvPr>
-            <p:ph type="sldNum" idx="5" sz="quarter"/>
-          </p:nvPr>
-        </p:nvSpPr>
-        <p:spPr/>
-      </p:sp>
-    </p:spTree>
-  </p:cSld>
-  <p:clrMapOvr>
-    <a:masterClrMapping/>
-  </p:clrMapOvr>
-</p:notes>
-</file>
-
-<file path=ppt/notesSlides/notesSlide4.xml><?xml version="1.0" encoding="utf-8"?>
-<p:notes xmlns:a="http://schemas.openxmlformats.org/drawingml/2006/main" xmlns:p="http://schemas.openxmlformats.org/presentationml/2006/main" xmlns:r="http://schemas.openxmlformats.org/officeDocument/2006/relationships">
-  <p:cSld>
-    <p:spTree>
-      <p:nvGrpSpPr>
-        <p:cNvPr id="1" name=""/>
-        <p:cNvGrpSpPr/>
-        <p:nvPr/>
-      </p:nvGrpSpPr>
-      <p:grpSpPr>
-        <a:xfrm>
-          <a:off x="0" y="0"/>
-          <a:ext cx="0" cy="0"/>
-          <a:chOff x="0" y="0"/>
-          <a:chExt cx="0" cy="0"/>
-        </a:xfrm>
-      </p:grpSpPr>
-      <p:sp>
-        <p:nvSpPr>
-          <p:cNvPr id="2" name="Slide Image Placeholder 1"/>
-          <p:cNvSpPr>
-            <a:spLocks noGrp="1"/>
-          </p:cNvSpPr>
-          <p:nvPr>
-            <p:ph type="sldImg" idx="2"/>
-          </p:nvPr>
-        </p:nvSpPr>
-        <p:spPr/>
-      </p:sp>
-      <p:sp>
-        <p:nvSpPr>
-          <p:cNvPr id="3" name="Notes Placeholder 2"/>
-          <p:cNvSpPr>
-            <a:spLocks noGrp="1"/>
-          </p:cNvSpPr>
-          <p:nvPr>
-            <p:ph type="body" idx="3" sz="quarter"/>
-          </p:nvPr>
-        </p:nvSpPr>
-        <p:spPr/>
-        <p:txBody>
-          <a:bodyPr/>
-          <a:lstStyle/>
-          <a:p>
-            <a:r>
-              <a:t>Jemima · Seis problemas, tres que no son de pantalla</a:t>
-            </a:r>
-          </a:p>
-          <a:p/>
-          <a:p>
-            <a:r>
-              <a:t>Ordenamos los seis problemas por su causa.</a:t>
-            </a:r>
-          </a:p>
-          <a:p>
-            <a:r>
-              <a:t>[CLIC] Los de gobierno: vecinos que no fueron consultados y un sistema que se percibe corrupto</a:t>
-            </a:r>
-          </a:p>
-          <a:p>
-            <a:r>
-              <a:t>porque nadie ve a dónde va el dinero.</a:t>
-            </a:r>
-          </a:p>
-          <a:p>
-            <a:r>
-              <a:t>[CLIC] Los de información: instrucciones confusas y no saber cómo reclamar una multa.</a:t>
-            </a:r>
-          </a:p>
-          <a:p>
-            <a:r>
-              <a:t>[CLIC] Los de capacidad: falta personal, pero el parquímetro ya podía cobrar con tarjeta y avisar</a:t>
-            </a:r>
-          </a:p>
-          <a:p>
-            <a:r>
-              <a:t>vandalismo; esas funciones estaban apagadas.</a:t>
-            </a:r>
-          </a:p>
-          <a:p>
-            <a:r>
-              <a:t>[CLIC] Y los cuidacarros, que el caso llama franeleros: apartan el lugar y cobran por él, o sea</a:t>
-            </a:r>
-          </a:p>
-          <a:p>
-            <a:r>
-              <a:t>que le compiten al parquímetro por el mismo espacio.</a:t>
-            </a:r>
-          </a:p>
-        </p:txBody>
-      </p:sp>
-      <p:sp>
-        <p:nvSpPr>
-          <p:cNvPr id="4" name="Slide Number Placeholder 3"/>
-          <p:cNvSpPr>
-            <a:spLocks noGrp="1"/>
-          </p:cNvSpPr>
-          <p:nvPr>
-            <p:ph type="sldNum" idx="5" sz="quarter"/>
-          </p:nvPr>
-        </p:nvSpPr>
-        <p:spPr/>
-      </p:sp>
-    </p:spTree>
-  </p:cSld>
-  <p:clrMapOvr>
-    <a:masterClrMapping/>
-  </p:clrMapOvr>
-</p:notes>
-</file>
-
-<file path=ppt/notesSlides/notesSlide5.xml><?xml version="1.0" encoding="utf-8"?>
-<p:notes xmlns:a="http://schemas.openxmlformats.org/drawingml/2006/main" xmlns:p="http://schemas.openxmlformats.org/presentationml/2006/main" xmlns:r="http://schemas.openxmlformats.org/officeDocument/2006/relationships">
-  <p:cSld>
-    <p:spTree>
-      <p:nvGrpSpPr>
-        <p:cNvPr id="1" name=""/>
-        <p:cNvGrpSpPr/>
-        <p:nvPr/>
-      </p:nvGrpSpPr>
-      <p:grpSpPr>
-        <a:xfrm>
-          <a:off x="0" y="0"/>
-          <a:ext cx="0" cy="0"/>
-          <a:chOff x="0" y="0"/>
-          <a:chExt cx="0" cy="0"/>
-        </a:xfrm>
-      </p:grpSpPr>
-      <p:sp>
-        <p:nvSpPr>
-          <p:cNvPr id="2" name="Slide Image Placeholder 1"/>
-          <p:cNvSpPr>
-            <a:spLocks noGrp="1"/>
-          </p:cNvSpPr>
-          <p:nvPr>
-            <p:ph type="sldImg" idx="2"/>
-          </p:nvPr>
-        </p:nvSpPr>
-        <p:spPr/>
-      </p:sp>
-      <p:sp>
-        <p:nvSpPr>
-          <p:cNvPr id="3" name="Notes Placeholder 2"/>
-          <p:cNvSpPr>
-            <a:spLocks noGrp="1"/>
-          </p:cNvSpPr>
-          <p:nvPr>
-            <p:ph type="body" idx="3" sz="quarter"/>
-          </p:nvPr>
-        </p:nvSpPr>
-        <p:spPr/>
-        <p:txBody>
-          <a:bodyPr/>
-          <a:lstStyle/>
-          <a:p>
-            <a:r>
-              <a:t>Jemima · Requisitos de desempeño y el 72 %</a:t>
-            </a:r>
-          </a:p>
-          <a:p/>
-          <a:p>
-            <a:r>
-              <a:t>Smartmedia acordó con SERVIparq qué tiene que poder hacer el conductor antes, durante y después de</a:t>
-            </a:r>
-          </a:p>
-          <a:p>
-            <a:r>
-              <a:t>usar el parquímetro.</a:t>
-            </a:r>
-          </a:p>
-          <a:p>
-            <a:r>
-              <a:t>[CLIC] Y le puso un número. Setenta y dos por ciento: el ochenta por ciento encuentra la</a:t>
-            </a:r>
-          </a:p>
-          <a:p>
-            <a:r>
-              <a:t>información, porque la gente va con prisa, por el noventa por ciento que la usa bien.</a:t>
-            </a:r>
-          </a:p>
-          <a:p>
-            <a:r>
-              <a:t>[CLIC] Nuestra mejora: el umbral por tarea, según lo que cuesta fallar. Pagar mal termina en una</a:t>
-            </a:r>
-          </a:p>
-          <a:p>
-            <a:r>
-              <a:t>multa injusta, así que ahí pedimos ochenta y uno, el máximo del método. Byron les explica cómo lo</a:t>
-            </a:r>
-          </a:p>
-          <a:p>
-            <a:r>
-              <a:t>resolvemos.</a:t>
-            </a:r>
-          </a:p>
-        </p:txBody>
-      </p:sp>
-      <p:sp>
-        <p:nvSpPr>
-          <p:cNvPr id="4" name="Slide Number Placeholder 3"/>
-          <p:cNvSpPr>
-            <a:spLocks noGrp="1"/>
-          </p:cNvSpPr>
-          <p:nvPr>
-            <p:ph type="sldNum" idx="5" sz="quarter"/>
-          </p:nvPr>
-        </p:nvSpPr>
-        <p:spPr/>
-      </p:sp>
-    </p:spTree>
-  </p:cSld>
-  <p:clrMapOvr>
-    <a:masterClrMapping/>
-  </p:clrMapOvr>
-</p:notes>
-</file>
-
-<file path=ppt/notesSlides/notesSlide6.xml><?xml version="1.0" encoding="utf-8"?>
-<p:notes xmlns:a="http://schemas.openxmlformats.org/drawingml/2006/main" xmlns:p="http://schemas.openxmlformats.org/presentationml/2006/main" xmlns:r="http://schemas.openxmlformats.org/officeDocument/2006/relationships">
-  <p:cSld>
-    <p:spTree>
-      <p:nvGrpSpPr>
-        <p:cNvPr id="1" name=""/>
-        <p:cNvGrpSpPr/>
-        <p:nvPr/>
-      </p:nvGrpSpPr>
-      <p:grpSpPr>
-        <a:xfrm>
-          <a:off x="0" y="0"/>
-          <a:ext cx="0" cy="0"/>
-          <a:chOff x="0" y="0"/>
-          <a:chExt cx="0" cy="0"/>
-        </a:xfrm>
-      </p:grpSpPr>
-      <p:sp>
-        <p:nvSpPr>
-          <p:cNvPr id="2" name="Slide Image Placeholder 1"/>
-          <p:cNvSpPr>
-            <a:spLocks noGrp="1"/>
-          </p:cNvSpPr>
-          <p:nvPr>
-            <p:ph type="sldImg" idx="2"/>
-          </p:nvPr>
-        </p:nvSpPr>
-        <p:spPr/>
-      </p:sp>
-      <p:sp>
-        <p:nvSpPr>
-          <p:cNvPr id="3" name="Notes Placeholder 2"/>
-          <p:cNvSpPr>
-            <a:spLocks noGrp="1"/>
-          </p:cNvSpPr>
-          <p:nvPr>
-            <p:ph type="body" idx="3" sz="quarter"/>
-          </p:nvPr>
-        </p:nvSpPr>
-        <p:spPr/>
-        <p:txBody>
-          <a:bodyPr/>
-          <a:lstStyle/>
-          <a:p>
-            <a:r>
-              <a:t>Byron · El negocio: cinco procesos</a:t>
-            </a:r>
-          </a:p>
-          <a:p/>
-          <a:p>
-            <a:r>
-              <a:t>Primero delimitamos el negocio: la gestión del estacionamiento en la vía pública. Los actores son el</a:t>
-            </a:r>
-          </a:p>
-          <a:p>
-            <a:r>
-              <a:t>conductor, el comité vecinal, la Delegación, el área de tránsito, el banco y el proveedor del equipo.</a:t>
-            </a:r>
-          </a:p>
-          <a:p>
-            <a:r>
-              <a:t>El verificador trabaja adentro, así que no es actor sino trabajador. Y el cuidacarros tampoco es</a:t>
-            </a:r>
-          </a:p>
-          <a:p>
-            <a:r>
-              <a:t>actor: no participa en el negocio de forma legal, pero igual tenemos que tomarlo en cuenta.</a:t>
-            </a:r>
-          </a:p>
-          <a:p>
-            <a:r>
-              <a:t>[CLIC] De ahí salen cinco procesos: concertar la zona, cobrar por placa, verificar y sancionar,</a:t>
-            </a:r>
-          </a:p>
-          <a:p>
-            <a:r>
-              <a:t>rendir cuentas y mantener la red. Cada uno será un servicio.</a:t>
-            </a:r>
-          </a:p>
-        </p:txBody>
-      </p:sp>
-      <p:sp>
-        <p:nvSpPr>
-          <p:cNvPr id="4" name="Slide Number Placeholder 3"/>
-          <p:cNvSpPr>
-            <a:spLocks noGrp="1"/>
-          </p:cNvSpPr>
-          <p:nvPr>
-            <p:ph type="sldNum" idx="5" sz="quarter"/>
-          </p:nvPr>
-        </p:nvSpPr>
-        <p:spPr/>
-      </p:sp>
-    </p:spTree>
-  </p:cSld>
-  <p:clrMapOvr>
-    <a:masterClrMapping/>
-  </p:clrMapOvr>
-</p:notes>
-</file>
-
-<file path=ppt/notesSlides/notesSlide7.xml><?xml version="1.0" encoding="utf-8"?>
-<p:notes xmlns:a="http://schemas.openxmlformats.org/drawingml/2006/main" xmlns:p="http://schemas.openxmlformats.org/presentationml/2006/main" xmlns:r="http://schemas.openxmlformats.org/officeDocument/2006/relationships">
-  <p:cSld>
-    <p:spTree>
-      <p:nvGrpSpPr>
-        <p:cNvPr id="1" name=""/>
-        <p:cNvGrpSpPr/>
-        <p:nvPr/>
-      </p:nvGrpSpPr>
-      <p:grpSpPr>
-        <a:xfrm>
-          <a:off x="0" y="0"/>
-          <a:ext cx="0" cy="0"/>
-          <a:chOff x="0" y="0"/>
-          <a:chExt cx="0" cy="0"/>
-        </a:xfrm>
-      </p:grpSpPr>
-      <p:sp>
-        <p:nvSpPr>
-          <p:cNvPr id="2" name="Slide Image Placeholder 1"/>
-          <p:cNvSpPr>
-            <a:spLocks noGrp="1"/>
-          </p:cNvSpPr>
-          <p:nvPr>
-            <p:ph type="sldImg" idx="2"/>
-          </p:nvPr>
-        </p:nvSpPr>
-        <p:spPr/>
-      </p:sp>
-      <p:sp>
-        <p:nvSpPr>
-          <p:cNvPr id="3" name="Notes Placeholder 2"/>
-          <p:cNvSpPr>
-            <a:spLocks noGrp="1"/>
-          </p:cNvSpPr>
-          <p:nvPr>
-            <p:ph type="body" idx="3" sz="quarter"/>
-          </p:nvPr>
-        </p:nvSpPr>
-        <p:spPr/>
-        <p:txBody>
-          <a:bodyPr/>
-          <a:lstStyle/>
-          <a:p>
-            <a:r>
-              <a:t>Byron · Cuatro alternativas</a:t>
-            </a:r>
-          </a:p>
-          <a:p/>
-          <a:p>
-            <a:r>
-              <a:t>Evaluamos cuatro soluciones contra los seis problemas y los drivers.</a:t>
-            </a:r>
-          </a:p>
-          <a:p>
-            <a:r>
-              <a:t>[CLIC] Uno: rediseñar solo la información. Barato, pero no toca la falta de personal.</a:t>
-            </a:r>
-          </a:p>
-          <a:p>
-            <a:r>
-              <a:t>[CLIC] Dos: pagar con el número de placa, con monedas, tarjeta o celular, usando el mismo equipo que ya se compró.</a:t>
-            </a:r>
-          </a:p>
-          <a:p>
-            <a:r>
-              <a:t>[CLIC] Tres: sensores por cajón y tarifa por demanda, como San Francisco. Caro y vulnerable al vandalismo.</a:t>
-            </a:r>
-          </a:p>
-          <a:p>
-            <a:r>
-              <a:t>[CLIC] Cuatro: gobierno comunitario, que no es software pero resuelve consulta y confianza.</a:t>
-            </a:r>
-          </a:p>
-          <a:p>
-            <a:r>
-              <a:t>Elegimos la dos como núcleo, con la uno adentro y la cuatro alrededor. La tres queda para después, cuando haya datos.</a:t>
-            </a:r>
-          </a:p>
-        </p:txBody>
-      </p:sp>
-      <p:sp>
-        <p:nvSpPr>
-          <p:cNvPr id="4" name="Slide Number Placeholder 3"/>
-          <p:cNvSpPr>
-            <a:spLocks noGrp="1"/>
-          </p:cNvSpPr>
-          <p:nvPr>
-            <p:ph type="sldNum" idx="5" sz="quarter"/>
-          </p:nvPr>
-        </p:nvSpPr>
-        <p:spPr/>
-      </p:sp>
-    </p:spTree>
-  </p:cSld>
-  <p:clrMapOvr>
-    <a:masterClrMapping/>
-  </p:clrMapOvr>
-</p:notes>
-</file>
-
-<file path=ppt/notesSlides/notesSlide8.xml><?xml version="1.0" encoding="utf-8"?>
-<p:notes xmlns:a="http://schemas.openxmlformats.org/drawingml/2006/main" xmlns:p="http://schemas.openxmlformats.org/presentationml/2006/main" xmlns:r="http://schemas.openxmlformats.org/officeDocument/2006/relationships">
-  <p:cSld>
-    <p:spTree>
-      <p:nvGrpSpPr>
-        <p:cNvPr id="1" name=""/>
-        <p:cNvGrpSpPr/>
-        <p:nvPr/>
-      </p:nvGrpSpPr>
-      <p:grpSpPr>
-        <a:xfrm>
-          <a:off x="0" y="0"/>
-          <a:ext cx="0" cy="0"/>
-          <a:chOff x="0" y="0"/>
-          <a:chExt cx="0" cy="0"/>
-        </a:xfrm>
-      </p:grpSpPr>
-      <p:sp>
-        <p:nvSpPr>
-          <p:cNvPr id="2" name="Slide Image Placeholder 1"/>
-          <p:cNvSpPr>
-            <a:spLocks noGrp="1"/>
-          </p:cNvSpPr>
-          <p:nvPr>
-            <p:ph type="sldImg" idx="2"/>
-          </p:nvPr>
-        </p:nvSpPr>
-        <p:spPr/>
-      </p:sp>
-      <p:sp>
-        <p:nvSpPr>
-          <p:cNvPr id="3" name="Notes Placeholder 2"/>
-          <p:cNvSpPr>
-            <a:spLocks noGrp="1"/>
-          </p:cNvSpPr>
-          <p:nvPr>
-            <p:ph type="body" idx="3" sz="quarter"/>
-          </p:nvPr>
-        </p:nvSpPr>
-        <p:spPr/>
-        <p:txBody>
-          <a:bodyPr/>
-          <a:lstStyle/>
-          <a:p>
-            <a:r>
-              <a:t>Byron · La arquitectura: SOA con eventos</a:t>
-            </a:r>
-          </a:p>
-          <a:p/>
-          <a:p>
-            <a:r>
-              <a:t>El estilo principal es SOA, arquitectura orientada a servicios: cada uno de los cinco procesos es un</a:t>
-            </a:r>
-          </a:p>
-          <a:p>
-            <a:r>
-              <a:t>servicio independiente. Es justo lo que dice la lámina de clase: desarrollar los procesos de negocio</a:t>
-            </a:r>
-          </a:p>
-          <a:p>
-            <a:r>
-              <a:t>como servicios.</a:t>
-            </a:r>
-          </a:p>
-          <a:p>
-            <a:r>
-              <a:t>[CLIC] Y los servicios se avisan con eventos. Cuando alguien paga, el parquímetro avisa «pago</a:t>
-            </a:r>
-          </a:p>
-          <a:p>
-            <a:r>
-              <a:t>registrado» y a ese aviso reaccionan la base de datos, las notificaciones y el tablero, sin que el</a:t>
-            </a:r>
-          </a:p>
-          <a:p>
-            <a:r>
-              <a:t>parquímetro tenga que conocerlos.</a:t>
-            </a:r>
-          </a:p>
-          <a:p>
-            <a:r>
-              <a:t>[CLIC] Cuatro decisiones cambian el día a día: el pago se liga a la placa y desaparece el boleto;</a:t>
-            </a:r>
-          </a:p>
-          <a:p>
-            <a:r>
-              <a:t>se encienden el pago con tarjeta y la alarma; la multa solo nace cuando el oficial confirma la</a:t>
-            </a:r>
-          </a:p>
-          <a:p>
-            <a:r>
-              <a:t>evidencia; y todo lo cobrado se publica.</a:t>
-            </a:r>
-          </a:p>
-        </p:txBody>
-      </p:sp>
-      <p:sp>
-        <p:nvSpPr>
-          <p:cNvPr id="4" name="Slide Number Placeholder 3"/>
-          <p:cNvSpPr>
-            <a:spLocks noGrp="1"/>
-          </p:cNvSpPr>
-          <p:nvPr>
-            <p:ph type="sldNum" idx="5" sz="quarter"/>
-          </p:nvPr>
-        </p:nvSpPr>
-        <p:spPr/>
-      </p:sp>
-    </p:spTree>
-  </p:cSld>
-  <p:clrMapOvr>
-    <a:masterClrMapping/>
-  </p:clrMapOvr>
-</p:notes>
-</file>
-
-<file path=ppt/notesSlides/notesSlide9.xml><?xml version="1.0" encoding="utf-8"?>
-<p:notes xmlns:a="http://schemas.openxmlformats.org/drawingml/2006/main" xmlns:p="http://schemas.openxmlformats.org/presentationml/2006/main" xmlns:r="http://schemas.openxmlformats.org/officeDocument/2006/relationships">
-  <p:cSld>
-    <p:spTree>
-      <p:nvGrpSpPr>
-        <p:cNvPr id="1" name=""/>
-        <p:cNvGrpSpPr/>
-        <p:nvPr/>
-      </p:nvGrpSpPr>
-      <p:grpSpPr>
-        <a:xfrm>
-          <a:off x="0" y="0"/>
-          <a:ext cx="0" cy="0"/>
-          <a:chOff x="0" y="0"/>
-          <a:chExt cx="0" cy="0"/>
-        </a:xfrm>
-      </p:grpSpPr>
-      <p:sp>
-        <p:nvSpPr>
-          <p:cNvPr id="2" name="Slide Image Placeholder 1"/>
-          <p:cNvSpPr>
-            <a:spLocks noGrp="1"/>
-          </p:cNvSpPr>
-          <p:nvPr>
-            <p:ph type="sldImg" idx="2"/>
-          </p:nvPr>
-        </p:nvSpPr>
-        <p:spPr/>
-      </p:sp>
-      <p:sp>
-        <p:nvSpPr>
-          <p:cNvPr id="3" name="Notes Placeholder 2"/>
-          <p:cNvSpPr>
-            <a:spLocks noGrp="1"/>
-          </p:cNvSpPr>
-          <p:nvPr>
-            <p:ph type="body" idx="3" sz="quarter"/>
-          </p:nvPr>
-        </p:nvSpPr>
-        <p:spPr/>
-        <p:txBody>
-          <a:bodyPr/>
-          <a:lstStyle/>
-          <a:p>
-            <a:r>
-              <a:t>Byron · Despliegue</a:t>
-            </a:r>
-          </a:p>
-          <a:p/>
-          <a:p>
-            <a:r>
-              <a:t>Así se despliega. Arriba, el parquímetro, el teléfono del conductor, el del verificador y la consola</a:t>
-            </a:r>
-          </a:p>
-          <a:p>
-            <a:r>
-              <a:t>de la Delegación. El parquímetro se conecta por la red celular y, si se cae la señal, sigue cobrando,</a:t>
-            </a:r>
-          </a:p>
-          <a:p>
-            <a:r>
-              <a:t>guarda los pagos y los manda cuando vuelve la conexión. Al centro, la nube con los seis servicios, la mensajería, la base de datos y la analítica;</a:t>
-            </a:r>
-          </a:p>
-          <a:p>
-            <a:r>
-              <a:t>abajo, una réplica en otra región; a la derecha, el banco y la autoridad de tránsito.</a:t>
-            </a:r>
-          </a:p>
-          <a:p>
-            <a:r>
-              <a:t>Jemima les muestra cómo medimos que esto funciona.</a:t>
-            </a:r>
-          </a:p>
-        </p:txBody>
-      </p:sp>
-      <p:sp>
-        <p:nvSpPr>
-          <p:cNvPr id="4" name="Slide Number Placeholder 3"/>
-          <p:cNvSpPr>
-            <a:spLocks noGrp="1"/>
-          </p:cNvSpPr>
-          <p:nvPr>
-            <p:ph type="sldNum" idx="5" sz="quarter"/>
-          </p:nvPr>
-        </p:nvSpPr>
-        <p:spPr/>
-      </p:sp>
-    </p:spTree>
-  </p:cSld>
-  <p:clrMapOvr>
-    <a:masterClrMapping/>
-  </p:clrMapOvr>
-</p:notes>
 </file>
 
 <file path=ppt/slideLayouts/slideLayout1.xml><?xml version="1.0" encoding="utf-8"?>

</xml_diff>

<commit_message>
feat(presentacion): guion con contexto para el público y fotos del parquímetro del caso
- Cada diapositiva dice qué se ve, qué aparece en cada clic, la idea clave y por qué aparece cada referencia.
- Glosario de palabras para explicar y respuestas listas para las preguntas probables.
- Diapositivas 2 y 4 con fotos del parquímetro tomadas del caso (Morales Zaragoza, 2015).

Co-Authored-By: Claude Opus 5.5 (1M context) <noreply@anthropic.com>
</commit_message>
<xml_diff>
--- a/presentacion/Grupo2_CasoParquimetros_Presentacion.pptx
+++ b/presentacion/Grupo2_CasoParquimetros_Presentacion.pptx
@@ -10420,30 +10420,155 @@
           </a:p>
         </p:txBody>
       </p:sp>
+      <p:sp>
+        <p:nvSpPr>
+          <p:cNvPr id="17" name="Rounded Rectangle 16"/>
+          <p:cNvSpPr/>
+          <p:nvPr/>
+        </p:nvSpPr>
+        <p:spPr>
+          <a:xfrm>
+            <a:off x="762000" y="3052572"/>
+            <a:ext cx="2540000" cy="3170428"/>
+          </a:xfrm>
+          <a:prstGeom prst="roundRect">
+            <a:avLst>
+              <a:gd name="adj" fmla="val 4000"/>
+            </a:avLst>
+          </a:prstGeom>
+          <a:solidFill>
+            <a:srgbClr val="FFFFFF"/>
+          </a:solidFill>
+          <a:ln>
+            <a:noFill/>
+          </a:ln>
+          <a:effectLst/>
+        </p:spPr>
+        <p:style>
+          <a:lnRef idx="1">
+            <a:schemeClr val="accent1"/>
+          </a:lnRef>
+          <a:fillRef idx="3">
+            <a:schemeClr val="accent1"/>
+          </a:fillRef>
+          <a:effectRef idx="2">
+            <a:schemeClr val="accent1"/>
+          </a:effectRef>
+          <a:fontRef idx="minor">
+            <a:schemeClr val="lt1"/>
+          </a:fontRef>
+        </p:style>
+        <p:txBody>
+          <a:bodyPr rtlCol="0" anchor="ctr"/>
+          <a:lstStyle/>
+          <a:p>
+            <a:pPr algn="ctr"/>
+          </a:p>
+        </p:txBody>
+      </p:sp>
+      <p:pic>
+        <p:nvPicPr>
+          <p:cNvPr id="18" name="Picture 17" descr="parquimetro-partes.png"/>
+          <p:cNvPicPr>
+            <a:picLocks noChangeAspect="1"/>
+          </p:cNvPicPr>
+          <p:nvPr/>
+        </p:nvPicPr>
+        <p:blipFill>
+          <a:blip r:embed="rId2"/>
+          <a:stretch>
+            <a:fillRect/>
+          </a:stretch>
+        </p:blipFill>
+        <p:spPr>
+          <a:xfrm>
+            <a:off x="857250" y="3492768"/>
+            <a:ext cx="2349500" cy="1756636"/>
+          </a:xfrm>
+          <a:prstGeom prst="rect">
+            <a:avLst/>
+          </a:prstGeom>
+        </p:spPr>
+      </p:pic>
+      <p:sp>
+        <p:nvSpPr>
+          <p:cNvPr id="19" name="TextBox 18"/>
+          <p:cNvSpPr txBox="1"/>
+          <p:nvPr/>
+        </p:nvSpPr>
+        <p:spPr>
+          <a:xfrm>
+            <a:off x="889000" y="5401804"/>
+            <a:ext cx="2286000" cy="381000"/>
+          </a:xfrm>
+          <a:prstGeom prst="rect">
+            <a:avLst/>
+          </a:prstGeom>
+          <a:noFill/>
+        </p:spPr>
+        <p:txBody>
+          <a:bodyPr wrap="square" lIns="0" rIns="0" tIns="0" bIns="0" anchor="t">
+            <a:noAutofit/>
+          </a:bodyPr>
+          <a:lstStyle/>
+          <a:p>
+            <a:pPr algn="ctr">
+              <a:lnSpc>
+                <a:spcPct val="112000"/>
+              </a:lnSpc>
+            </a:pPr>
+            <a:r>
+              <a:rPr sz="1300" b="0">
+                <a:solidFill>
+                  <a:srgbClr val="444A52"/>
+                </a:solidFill>
+                <a:latin typeface="Arial"/>
+              </a:rPr>
+              <a:t>El parquímetro de SERVIparq</a:t>
+            </a:r>
+          </a:p>
+          <a:p>
+            <a:pPr algn="ctr">
+              <a:lnSpc>
+                <a:spcPct val="112000"/>
+              </a:lnSpc>
+            </a:pPr>
+            <a:r>
+              <a:rPr sz="1300" b="0">
+                <a:solidFill>
+                  <a:srgbClr val="444A52"/>
+                </a:solidFill>
+                <a:latin typeface="Arial"/>
+              </a:rPr>
+              <a:t>(Morales Zaragoza, 2015)</a:t>
+            </a:r>
+          </a:p>
+        </p:txBody>
+      </p:sp>
       <p:grpSp>
         <p:nvGrpSpPr>
-          <p:cNvPr id="17" name="Group 16"/>
+          <p:cNvPr id="20" name="Group 19"/>
           <p:cNvGrpSpPr/>
           <p:nvPr/>
         </p:nvGrpSpPr>
         <p:grpSpPr>
           <a:xfrm>
-            <a:off x="762000" y="3052572"/>
-            <a:ext cx="3429000" cy="3170428"/>
-            <a:chOff x="762000" y="3052572"/>
-            <a:chExt cx="3429000" cy="3170428"/>
+            <a:off x="3429000" y="3052572"/>
+            <a:ext cx="2540000" cy="3170428"/>
+            <a:chOff x="3429000" y="3052572"/>
+            <a:chExt cx="2540000" cy="3170428"/>
           </a:xfrm>
         </p:grpSpPr>
         <p:sp>
           <p:nvSpPr>
-            <p:cNvPr id="18" name="Rounded Rectangle 17"/>
+            <p:cNvPr id="21" name="Rounded Rectangle 20"/>
             <p:cNvSpPr/>
             <p:nvPr/>
           </p:nvSpPr>
           <p:spPr>
             <a:xfrm>
-              <a:off x="762000" y="3052572"/>
-              <a:ext cx="3429000" cy="3170428"/>
+              <a:off x="3429000" y="3052572"/>
+              <a:ext cx="2540000" cy="3170428"/>
             </a:xfrm>
             <a:prstGeom prst="roundRect">
               <a:avLst>
@@ -10484,14 +10609,14 @@
         </p:sp>
         <p:sp>
           <p:nvSpPr>
-            <p:cNvPr id="19" name="TextBox 18"/>
+            <p:cNvPr id="22" name="TextBox 21"/>
             <p:cNvSpPr txBox="1"/>
             <p:nvPr/>
           </p:nvSpPr>
           <p:spPr>
             <a:xfrm>
-              <a:off x="1016000" y="3281172"/>
-              <a:ext cx="2921000" cy="720090"/>
+              <a:off x="3683000" y="3281172"/>
+              <a:ext cx="2032000" cy="586740"/>
             </a:xfrm>
             <a:prstGeom prst="rect">
               <a:avLst/>
@@ -10510,27 +10635,27 @@
                 </a:lnSpc>
               </a:pPr>
               <a:r>
-                <a:rPr sz="5400" b="1">
+                <a:rPr sz="4400" b="1">
                   <a:solidFill>
                     <a:srgbClr val="5AA2FF"/>
                   </a:solidFill>
                   <a:latin typeface="Arial"/>
                 </a:rPr>
-                <a:t>70 / 30</a:t>
+                <a:t>70/30</a:t>
               </a:r>
             </a:p>
           </p:txBody>
         </p:sp>
         <p:sp>
           <p:nvSpPr>
-            <p:cNvPr id="20" name="TextBox 19"/>
+            <p:cNvPr id="23" name="TextBox 22"/>
             <p:cNvSpPr txBox="1"/>
             <p:nvPr/>
           </p:nvSpPr>
           <p:spPr>
             <a:xfrm>
-              <a:off x="1016000" y="4052062"/>
-              <a:ext cx="2921000" cy="586740"/>
+              <a:off x="3683000" y="3918712"/>
+              <a:ext cx="2032000" cy="880110"/>
             </a:xfrm>
             <a:prstGeom prst="rect">
               <a:avLst/>
@@ -10562,14 +10687,14 @@
         </p:sp>
         <p:sp>
           <p:nvSpPr>
-            <p:cNvPr id="21" name="TextBox 20"/>
+            <p:cNvPr id="24" name="TextBox 23"/>
             <p:cNvSpPr txBox="1"/>
             <p:nvPr/>
           </p:nvSpPr>
           <p:spPr>
             <a:xfrm>
-              <a:off x="1016000" y="4727702"/>
-              <a:ext cx="2921000" cy="1015594"/>
+              <a:off x="3683000" y="4887722"/>
+              <a:ext cx="2032000" cy="1194816"/>
             </a:xfrm>
             <a:prstGeom prst="rect">
               <a:avLst/>
@@ -10588,7 +10713,7 @@
                 </a:lnSpc>
               </a:pPr>
               <a:r>
-                <a:rPr sz="1700" b="0">
+                <a:rPr sz="1600" b="0">
                   <a:solidFill>
                     <a:srgbClr val="A8AEB8"/>
                   </a:solidFill>
@@ -10604,7 +10729,7 @@
                 </a:lnSpc>
               </a:pPr>
               <a:r>
-                <a:rPr sz="1700" b="0">
+                <a:rPr sz="1600" b="0">
                   <a:solidFill>
                     <a:srgbClr val="A8AEB8"/>
                   </a:solidFill>
@@ -10618,28 +10743,28 @@
       </p:grpSp>
       <p:grpSp>
         <p:nvGrpSpPr>
-          <p:cNvPr id="22" name="Group 21"/>
+          <p:cNvPr id="25" name="Group 24"/>
           <p:cNvGrpSpPr/>
           <p:nvPr/>
         </p:nvGrpSpPr>
         <p:grpSpPr>
           <a:xfrm>
-            <a:off x="4381500" y="3052572"/>
-            <a:ext cx="3429000" cy="3170428"/>
-            <a:chOff x="4381500" y="3052572"/>
-            <a:chExt cx="3429000" cy="3170428"/>
+            <a:off x="6096000" y="3052572"/>
+            <a:ext cx="2540000" cy="3170428"/>
+            <a:chOff x="6096000" y="3052572"/>
+            <a:chExt cx="2540000" cy="3170428"/>
           </a:xfrm>
         </p:grpSpPr>
         <p:sp>
           <p:nvSpPr>
-            <p:cNvPr id="23" name="Rounded Rectangle 22"/>
+            <p:cNvPr id="26" name="Rounded Rectangle 25"/>
             <p:cNvSpPr/>
             <p:nvPr/>
           </p:nvSpPr>
           <p:spPr>
             <a:xfrm>
-              <a:off x="4381500" y="3052572"/>
-              <a:ext cx="3429000" cy="3170428"/>
+              <a:off x="6096000" y="3052572"/>
+              <a:ext cx="2540000" cy="3170428"/>
             </a:xfrm>
             <a:prstGeom prst="roundRect">
               <a:avLst>
@@ -10680,14 +10805,14 @@
         </p:sp>
         <p:sp>
           <p:nvSpPr>
-            <p:cNvPr id="24" name="TextBox 23"/>
+            <p:cNvPr id="27" name="TextBox 26"/>
             <p:cNvSpPr txBox="1"/>
             <p:nvPr/>
           </p:nvSpPr>
           <p:spPr>
             <a:xfrm>
-              <a:off x="4635500" y="3281172"/>
-              <a:ext cx="2921000" cy="720090"/>
+              <a:off x="6350000" y="3281172"/>
+              <a:ext cx="2032000" cy="586740"/>
             </a:xfrm>
             <a:prstGeom prst="rect">
               <a:avLst/>
@@ -10706,7 +10831,7 @@
                 </a:lnSpc>
               </a:pPr>
               <a:r>
-                <a:rPr sz="5400" b="1">
+                <a:rPr sz="4400" b="1">
                   <a:solidFill>
                     <a:srgbClr val="5AA2FF"/>
                   </a:solidFill>
@@ -10719,14 +10844,14 @@
         </p:sp>
         <p:sp>
           <p:nvSpPr>
-            <p:cNvPr id="25" name="TextBox 24"/>
+            <p:cNvPr id="28" name="TextBox 27"/>
             <p:cNvSpPr txBox="1"/>
             <p:nvPr/>
           </p:nvSpPr>
           <p:spPr>
             <a:xfrm>
-              <a:off x="4635500" y="4052062"/>
-              <a:ext cx="2921000" cy="586740"/>
+              <a:off x="6350000" y="3918712"/>
+              <a:ext cx="2032000" cy="880110"/>
             </a:xfrm>
             <a:prstGeom prst="rect">
               <a:avLst/>
@@ -10758,14 +10883,14 @@
         </p:sp>
         <p:sp>
           <p:nvSpPr>
-            <p:cNvPr id="26" name="TextBox 25"/>
+            <p:cNvPr id="29" name="TextBox 28"/>
             <p:cNvSpPr txBox="1"/>
             <p:nvPr/>
           </p:nvSpPr>
           <p:spPr>
             <a:xfrm>
-              <a:off x="4635500" y="4727702"/>
-              <a:ext cx="2921000" cy="1269492"/>
+              <a:off x="6350000" y="4887722"/>
+              <a:ext cx="2032000" cy="1194816"/>
             </a:xfrm>
             <a:prstGeom prst="rect">
               <a:avLst/>
@@ -10784,13 +10909,13 @@
                 </a:lnSpc>
               </a:pPr>
               <a:r>
-                <a:rPr sz="1700" b="0">
+                <a:rPr sz="1600" b="0">
                   <a:solidFill>
                     <a:srgbClr val="A8AEB8"/>
                   </a:solidFill>
                   <a:latin typeface="Arial"/>
                 </a:rPr>
-                <a:t>Vecinos no consultados, cuidacarros, instrucciones confusas, reclamos sin respuesta, falta de personal y desconfianza.</a:t>
+                <a:t>Consulta, cuidacarros, instrucciones, reclamos, personal y desconfianza.</a:t>
               </a:r>
             </a:p>
           </p:txBody>
@@ -10798,28 +10923,28 @@
       </p:grpSp>
       <p:grpSp>
         <p:nvGrpSpPr>
-          <p:cNvPr id="27" name="Group 26"/>
+          <p:cNvPr id="30" name="Group 29"/>
           <p:cNvGrpSpPr/>
           <p:nvPr/>
         </p:nvGrpSpPr>
         <p:grpSpPr>
           <a:xfrm>
-            <a:off x="8001000" y="3052572"/>
-            <a:ext cx="3429000" cy="3170428"/>
-            <a:chOff x="8001000" y="3052572"/>
-            <a:chExt cx="3429000" cy="3170428"/>
+            <a:off x="8763000" y="3052572"/>
+            <a:ext cx="2667000" cy="3170428"/>
+            <a:chOff x="8763000" y="3052572"/>
+            <a:chExt cx="2667000" cy="3170428"/>
           </a:xfrm>
         </p:grpSpPr>
         <p:sp>
           <p:nvSpPr>
-            <p:cNvPr id="28" name="Rounded Rectangle 27"/>
+            <p:cNvPr id="31" name="Rounded Rectangle 30"/>
             <p:cNvSpPr/>
             <p:nvPr/>
           </p:nvSpPr>
           <p:spPr>
             <a:xfrm>
-              <a:off x="8001000" y="3052572"/>
-              <a:ext cx="3429000" cy="3170428"/>
+              <a:off x="8763000" y="3052572"/>
+              <a:ext cx="2667000" cy="3170428"/>
             </a:xfrm>
             <a:prstGeom prst="roundRect">
               <a:avLst>
@@ -10860,21 +10985,21 @@
         </p:sp>
         <p:pic>
           <p:nvPicPr>
-            <p:cNvPr id="29" name="Picture 28" descr="users-5AA2FF.png"/>
+            <p:cNvPr id="32" name="Picture 31" descr="users-5AA2FF.png"/>
             <p:cNvPicPr>
               <a:picLocks noChangeAspect="1"/>
             </p:cNvPicPr>
             <p:nvPr/>
           </p:nvPicPr>
           <p:blipFill>
-            <a:blip r:embed="rId2"/>
+            <a:blip r:embed="rId3"/>
             <a:stretch>
               <a:fillRect/>
             </a:stretch>
           </p:blipFill>
           <p:spPr>
             <a:xfrm>
-              <a:off x="8255000" y="3281172"/>
+              <a:off x="9017000" y="3281172"/>
               <a:ext cx="406400" cy="406400"/>
             </a:xfrm>
             <a:prstGeom prst="rect">
@@ -10884,14 +11009,14 @@
         </p:pic>
         <p:sp>
           <p:nvSpPr>
-            <p:cNvPr id="30" name="TextBox 29"/>
+            <p:cNvPr id="33" name="TextBox 32"/>
             <p:cNvSpPr txBox="1"/>
             <p:nvPr/>
           </p:nvSpPr>
           <p:spPr>
             <a:xfrm>
-              <a:off x="8255000" y="3865372"/>
-              <a:ext cx="2921000" cy="586740"/>
+              <a:off x="9017000" y="3865372"/>
+              <a:ext cx="2159000" cy="586740"/>
             </a:xfrm>
             <a:prstGeom prst="rect">
               <a:avLst/>
@@ -10916,21 +11041,21 @@
                   </a:solidFill>
                   <a:latin typeface="Arial"/>
                 </a:rPr>
-                <a:t>Smartmedia mide con personas</a:t>
+                <a:t>Pruebas con personas</a:t>
               </a:r>
             </a:p>
           </p:txBody>
         </p:sp>
         <p:sp>
           <p:nvSpPr>
-            <p:cNvPr id="31" name="TextBox 30"/>
+            <p:cNvPr id="34" name="TextBox 33"/>
             <p:cNvSpPr txBox="1"/>
             <p:nvPr/>
           </p:nvSpPr>
           <p:spPr>
             <a:xfrm>
-              <a:off x="8255000" y="4541012"/>
-              <a:ext cx="2921000" cy="1523390"/>
+              <a:off x="9017000" y="4541012"/>
+              <a:ext cx="2159000" cy="1194816"/>
             </a:xfrm>
             <a:prstGeom prst="rect">
               <a:avLst/>
@@ -10949,13 +11074,13 @@
                 </a:lnSpc>
               </a:pPr>
               <a:r>
-                <a:rPr sz="1700" b="0">
+                <a:rPr sz="1600" b="0">
                   <a:solidFill>
                     <a:srgbClr val="A8AEB8"/>
                   </a:solidFill>
                   <a:latin typeface="Arial"/>
                 </a:rPr>
-                <a:t>Pide tareas reales con el parquímetro y mide si la gente encuentra y entiende la información. Hasta recrearon una calle en una sala.</a:t>
+                <a:t>Smartmedia mide con tareas reales si la gente encuentra y entiende la información.</a:t>
               </a:r>
             </a:p>
           </p:txBody>
@@ -11012,7 +11137,7 @@
                                           </p:stCondLst>
                                         </p:cTn>
                                         <p:tgtEl>
-                                          <p:spTgt spid="17"/>
+                                          <p:spTgt spid="20"/>
                                         </p:tgtEl>
                                         <p:attrNameLst>
                                           <p:attrName>style.visibility</p:attrName>
@@ -11026,7 +11151,7 @@
                                       <p:cBhvr>
                                         <p:cTn id="5" dur="500"/>
                                         <p:tgtEl>
-                                          <p:spTgt spid="17"/>
+                                          <p:spTgt spid="20"/>
                                         </p:tgtEl>
                                       </p:cBhvr>
                                     </p:animEffect>
@@ -11034,7 +11159,7 @@
                                       <p:cBhvr>
                                         <p:cTn id="6" dur="500" fill="hold"/>
                                         <p:tgtEl>
-                                          <p:spTgt spid="17"/>
+                                          <p:spTgt spid="20"/>
                                         </p:tgtEl>
                                         <p:attrNameLst>
                                           <p:attrName>ppt_x</p:attrName>
@@ -11057,7 +11182,7 @@
                                       <p:cBhvr>
                                         <p:cTn id="7" dur="500" decel="100000" fill="hold"/>
                                         <p:tgtEl>
-                                          <p:spTgt spid="17"/>
+                                          <p:spTgt spid="20"/>
                                         </p:tgtEl>
                                         <p:attrNameLst>
                                           <p:attrName>ppt_y</p:attrName>
@@ -11111,7 +11236,7 @@
                                           </p:stCondLst>
                                         </p:cTn>
                                         <p:tgtEl>
-                                          <p:spTgt spid="22"/>
+                                          <p:spTgt spid="25"/>
                                         </p:tgtEl>
                                         <p:attrNameLst>
                                           <p:attrName>style.visibility</p:attrName>
@@ -11125,7 +11250,7 @@
                                       <p:cBhvr>
                                         <p:cTn id="12" dur="500"/>
                                         <p:tgtEl>
-                                          <p:spTgt spid="22"/>
+                                          <p:spTgt spid="25"/>
                                         </p:tgtEl>
                                       </p:cBhvr>
                                     </p:animEffect>
@@ -11133,7 +11258,7 @@
                                       <p:cBhvr>
                                         <p:cTn id="13" dur="500" fill="hold"/>
                                         <p:tgtEl>
-                                          <p:spTgt spid="22"/>
+                                          <p:spTgt spid="25"/>
                                         </p:tgtEl>
                                         <p:attrNameLst>
                                           <p:attrName>ppt_x</p:attrName>
@@ -11156,7 +11281,7 @@
                                       <p:cBhvr>
                                         <p:cTn id="14" dur="500" decel="100000" fill="hold"/>
                                         <p:tgtEl>
-                                          <p:spTgt spid="22"/>
+                                          <p:spTgt spid="25"/>
                                         </p:tgtEl>
                                         <p:attrNameLst>
                                           <p:attrName>ppt_y</p:attrName>
@@ -11210,7 +11335,7 @@
                                           </p:stCondLst>
                                         </p:cTn>
                                         <p:tgtEl>
-                                          <p:spTgt spid="27"/>
+                                          <p:spTgt spid="30"/>
                                         </p:tgtEl>
                                         <p:attrNameLst>
                                           <p:attrName>style.visibility</p:attrName>
@@ -11224,7 +11349,7 @@
                                       <p:cBhvr>
                                         <p:cTn id="19" dur="500"/>
                                         <p:tgtEl>
-                                          <p:spTgt spid="27"/>
+                                          <p:spTgt spid="30"/>
                                         </p:tgtEl>
                                       </p:cBhvr>
                                     </p:animEffect>
@@ -11232,7 +11357,7 @@
                                       <p:cBhvr>
                                         <p:cTn id="20" dur="500" fill="hold"/>
                                         <p:tgtEl>
-                                          <p:spTgt spid="27"/>
+                                          <p:spTgt spid="30"/>
                                         </p:tgtEl>
                                         <p:attrNameLst>
                                           <p:attrName>ppt_x</p:attrName>
@@ -11255,7 +11380,7 @@
                                       <p:cBhvr>
                                         <p:cTn id="21" dur="500" decel="100000" fill="hold"/>
                                         <p:tgtEl>
-                                          <p:spTgt spid="27"/>
+                                          <p:spTgt spid="30"/>
                                         </p:tgtEl>
                                         <p:attrNameLst>
                                           <p:attrName>ppt_y</p:attrName>
@@ -13368,7 +13493,7 @@
           </p:nvSpPr>
           <p:spPr>
             <a:xfrm>
-              <a:off x="1016000" y="3077464"/>
+              <a:off x="1016000" y="3497364"/>
               <a:ext cx="2032000" cy="613410"/>
             </a:xfrm>
             <a:prstGeom prst="rect">
@@ -13407,7 +13532,7 @@
           </p:nvSpPr>
           <p:spPr>
             <a:xfrm>
-              <a:off x="1016000" y="3779774"/>
+              <a:off x="1016000" y="4199674"/>
               <a:ext cx="2032000" cy="1344168"/>
             </a:xfrm>
             <a:prstGeom prst="rect">
@@ -13519,7 +13644,7 @@
         </p:sp>
         <p:pic>
           <p:nvPicPr>
-            <p:cNvPr id="23" name="Picture 22" descr="map-pin-5AA2FF.png"/>
+            <p:cNvPr id="23" name="Picture 22" descr="parquimetro-panel-de-uso.png"/>
             <p:cNvPicPr>
               <a:picLocks noChangeAspect="1"/>
             </p:cNvPicPr>
@@ -13534,7 +13659,7 @@
           <p:spPr>
             <a:xfrm>
               <a:off x="3683000" y="2493264"/>
-              <a:ext cx="406400" cy="406400"/>
+              <a:ext cx="2032000" cy="915200"/>
             </a:xfrm>
             <a:prstGeom prst="rect">
               <a:avLst/>
@@ -13549,7 +13674,7 @@
           </p:nvSpPr>
           <p:spPr>
             <a:xfrm>
-              <a:off x="3683000" y="3077464"/>
+              <a:off x="3683000" y="3497364"/>
               <a:ext cx="2032000" cy="613410"/>
             </a:xfrm>
             <a:prstGeom prst="rect">
@@ -13588,7 +13713,7 @@
           </p:nvSpPr>
           <p:spPr>
             <a:xfrm>
-              <a:off x="3683000" y="3779774"/>
+              <a:off x="3683000" y="4199674"/>
               <a:ext cx="2032000" cy="1881835"/>
             </a:xfrm>
             <a:prstGeom prst="rect">
@@ -13730,7 +13855,7 @@
           </p:nvSpPr>
           <p:spPr>
             <a:xfrm>
-              <a:off x="6350000" y="3077464"/>
+              <a:off x="6350000" y="3497364"/>
               <a:ext cx="2032000" cy="613410"/>
             </a:xfrm>
             <a:prstGeom prst="rect">
@@ -13769,7 +13894,7 @@
           </p:nvSpPr>
           <p:spPr>
             <a:xfrm>
-              <a:off x="6350000" y="3779774"/>
+              <a:off x="6350000" y="4199674"/>
               <a:ext cx="2032000" cy="1881835"/>
             </a:xfrm>
             <a:prstGeom prst="rect">
@@ -13895,7 +14020,7 @@
           </p:nvSpPr>
           <p:spPr>
             <a:xfrm>
-              <a:off x="9017000" y="3077464"/>
+              <a:off x="9017000" y="3497364"/>
               <a:ext cx="2159000" cy="613410"/>
             </a:xfrm>
             <a:prstGeom prst="rect">
@@ -13934,7 +14059,7 @@
           </p:nvSpPr>
           <p:spPr>
             <a:xfrm>
-              <a:off x="9017000" y="3779774"/>
+              <a:off x="9017000" y="4199674"/>
               <a:ext cx="2159000" cy="1344168"/>
             </a:xfrm>
             <a:prstGeom prst="rect">

</xml_diff>